<commit_message>
Adopt the wheel as the brand mark
A hub, eight spokes through a ring, eight terminal nodes. It replaces
the hexagon-and-nodes mark everywhere it appeared: the masthead, the
Assistant button, and now the sign-in card and the orientation page,
which had no mark at all.

Drawn in currentColor rather than a fixed hex, so it takes the ink of
whatever it sits on and follows light and dark without a second copy.
The old masthead mark still had fill="#1A1613" on its nodes — an ink
colour from before the redesign, which on the dark ground rendered them
as very nearly nothing.

All four pages get it as a favicon, which none of them had. The deck
draws it with shapes rather than placing an SVG, because PowerPoint's
SVG support is uneven across versions and this is nine circles and four
lines. logo.svg holds the mark on its own for anywhere outside this repo
that needs it.

Co-Authored-By: Claude Opus 5 <noreply@anthropic.com>
</commit_message>
<xml_diff>
--- a/slides/PBL-orientation.pptx
+++ b/slides/PBL-orientation.pptx
@@ -2232,7 +2232,301 @@
       </p:sp>
       <p:sp>
         <p:nvSpPr>
-          <p:cNvPr id="3" name="Text 1"/>
+          <p:cNvPr id="3" name="Shape 1"/>
+          <p:cNvSpPr/>
+          <p:nvPr/>
+        </p:nvSpPr>
+        <p:spPr>
+          <a:xfrm>
+            <a:off x="1247973" y="1481328"/>
+            <a:ext cx="539862" cy="0"/>
+          </a:xfrm>
+          <a:prstGeom prst="line">
+            <a:avLst/>
+          </a:prstGeom>
+          <a:noFill/>
+          <a:ln w="27651">
+            <a:solidFill>
+              <a:srgbClr val="E9EBDF"/>
+            </a:solidFill>
+            <a:prstDash val="solid"/>
+          </a:ln>
+        </p:spPr>
+      </p:sp>
+      <p:sp>
+        <p:nvSpPr>
+          <p:cNvPr id="4" name="Shape 2"/>
+          <p:cNvSpPr/>
+          <p:nvPr/>
+        </p:nvSpPr>
+        <p:spPr>
+          <a:xfrm>
+            <a:off x="1517904" y="1211397"/>
+            <a:ext cx="0" cy="539862"/>
+          </a:xfrm>
+          <a:prstGeom prst="line">
+            <a:avLst/>
+          </a:prstGeom>
+          <a:noFill/>
+          <a:ln w="27651">
+            <a:solidFill>
+              <a:srgbClr val="E9EBDF"/>
+            </a:solidFill>
+            <a:prstDash val="solid"/>
+          </a:ln>
+        </p:spPr>
+      </p:sp>
+      <p:sp>
+        <p:nvSpPr>
+          <p:cNvPr id="5" name="Shape 3"/>
+          <p:cNvSpPr/>
+          <p:nvPr/>
+        </p:nvSpPr>
+        <p:spPr>
+          <a:xfrm>
+            <a:off x="1327036" y="1290460"/>
+            <a:ext cx="381736" cy="381736"/>
+          </a:xfrm>
+          <a:prstGeom prst="line">
+            <a:avLst/>
+          </a:prstGeom>
+          <a:noFill/>
+          <a:ln w="27651">
+            <a:solidFill>
+              <a:srgbClr val="E9EBDF"/>
+            </a:solidFill>
+            <a:prstDash val="solid"/>
+          </a:ln>
+        </p:spPr>
+      </p:sp>
+      <p:sp>
+        <p:nvSpPr>
+          <p:cNvPr id="6" name="Shape 4"/>
+          <p:cNvSpPr/>
+          <p:nvPr/>
+        </p:nvSpPr>
+        <p:spPr>
+          <a:xfrm flipV="1">
+            <a:off x="1327036" y="1290460"/>
+            <a:ext cx="381736" cy="381736"/>
+          </a:xfrm>
+          <a:prstGeom prst="line">
+            <a:avLst/>
+          </a:prstGeom>
+          <a:noFill/>
+          <a:ln w="27651">
+            <a:solidFill>
+              <a:srgbClr val="E9EBDF"/>
+            </a:solidFill>
+            <a:prstDash val="solid"/>
+          </a:ln>
+        </p:spPr>
+      </p:sp>
+      <p:sp>
+        <p:nvSpPr>
+          <p:cNvPr id="7" name="Shape 5"/>
+          <p:cNvSpPr/>
+          <p:nvPr/>
+        </p:nvSpPr>
+        <p:spPr>
+          <a:xfrm>
+            <a:off x="1350020" y="1313444"/>
+            <a:ext cx="335768" cy="335768"/>
+          </a:xfrm>
+          <a:prstGeom prst="ellipse">
+            <a:avLst/>
+          </a:prstGeom>
+          <a:ln w="27651">
+            <a:solidFill>
+              <a:srgbClr val="E9EBDF"/>
+            </a:solidFill>
+            <a:prstDash val="solid"/>
+          </a:ln>
+        </p:spPr>
+      </p:sp>
+      <p:sp>
+        <p:nvSpPr>
+          <p:cNvPr id="8" name="Shape 6"/>
+          <p:cNvSpPr/>
+          <p:nvPr/>
+        </p:nvSpPr>
+        <p:spPr>
+          <a:xfrm>
+            <a:off x="1729898" y="1423392"/>
+            <a:ext cx="115873" cy="115873"/>
+          </a:xfrm>
+          <a:prstGeom prst="ellipse">
+            <a:avLst/>
+          </a:prstGeom>
+          <a:solidFill>
+            <a:srgbClr val="E9EBDF"/>
+          </a:solidFill>
+          <a:ln/>
+        </p:spPr>
+      </p:sp>
+      <p:sp>
+        <p:nvSpPr>
+          <p:cNvPr id="9" name="Shape 7"/>
+          <p:cNvSpPr/>
+          <p:nvPr/>
+        </p:nvSpPr>
+        <p:spPr>
+          <a:xfrm>
+            <a:off x="1650838" y="1232522"/>
+            <a:ext cx="115873" cy="115873"/>
+          </a:xfrm>
+          <a:prstGeom prst="ellipse">
+            <a:avLst/>
+          </a:prstGeom>
+          <a:solidFill>
+            <a:srgbClr val="E9EBDF"/>
+          </a:solidFill>
+          <a:ln/>
+        </p:spPr>
+      </p:sp>
+      <p:sp>
+        <p:nvSpPr>
+          <p:cNvPr id="10" name="Shape 8"/>
+          <p:cNvSpPr/>
+          <p:nvPr/>
+        </p:nvSpPr>
+        <p:spPr>
+          <a:xfrm>
+            <a:off x="1459968" y="1153461"/>
+            <a:ext cx="115873" cy="115873"/>
+          </a:xfrm>
+          <a:prstGeom prst="ellipse">
+            <a:avLst/>
+          </a:prstGeom>
+          <a:solidFill>
+            <a:srgbClr val="E9EBDF"/>
+          </a:solidFill>
+          <a:ln/>
+        </p:spPr>
+      </p:sp>
+      <p:sp>
+        <p:nvSpPr>
+          <p:cNvPr id="11" name="Shape 9"/>
+          <p:cNvSpPr/>
+          <p:nvPr/>
+        </p:nvSpPr>
+        <p:spPr>
+          <a:xfrm>
+            <a:off x="1269098" y="1232522"/>
+            <a:ext cx="115873" cy="115873"/>
+          </a:xfrm>
+          <a:prstGeom prst="ellipse">
+            <a:avLst/>
+          </a:prstGeom>
+          <a:solidFill>
+            <a:srgbClr val="E9EBDF"/>
+          </a:solidFill>
+          <a:ln/>
+        </p:spPr>
+      </p:sp>
+      <p:sp>
+        <p:nvSpPr>
+          <p:cNvPr id="12" name="Shape 10"/>
+          <p:cNvSpPr/>
+          <p:nvPr/>
+        </p:nvSpPr>
+        <p:spPr>
+          <a:xfrm>
+            <a:off x="1190037" y="1423392"/>
+            <a:ext cx="115873" cy="115873"/>
+          </a:xfrm>
+          <a:prstGeom prst="ellipse">
+            <a:avLst/>
+          </a:prstGeom>
+          <a:solidFill>
+            <a:srgbClr val="E9EBDF"/>
+          </a:solidFill>
+          <a:ln/>
+        </p:spPr>
+      </p:sp>
+      <p:sp>
+        <p:nvSpPr>
+          <p:cNvPr id="13" name="Shape 11"/>
+          <p:cNvSpPr/>
+          <p:nvPr/>
+        </p:nvSpPr>
+        <p:spPr>
+          <a:xfrm>
+            <a:off x="1269098" y="1614262"/>
+            <a:ext cx="115873" cy="115873"/>
+          </a:xfrm>
+          <a:prstGeom prst="ellipse">
+            <a:avLst/>
+          </a:prstGeom>
+          <a:solidFill>
+            <a:srgbClr val="E9EBDF"/>
+          </a:solidFill>
+          <a:ln/>
+        </p:spPr>
+      </p:sp>
+      <p:sp>
+        <p:nvSpPr>
+          <p:cNvPr id="14" name="Shape 12"/>
+          <p:cNvSpPr/>
+          <p:nvPr/>
+        </p:nvSpPr>
+        <p:spPr>
+          <a:xfrm>
+            <a:off x="1459968" y="1693322"/>
+            <a:ext cx="115873" cy="115873"/>
+          </a:xfrm>
+          <a:prstGeom prst="ellipse">
+            <a:avLst/>
+          </a:prstGeom>
+          <a:solidFill>
+            <a:srgbClr val="E9EBDF"/>
+          </a:solidFill>
+          <a:ln/>
+        </p:spPr>
+      </p:sp>
+      <p:sp>
+        <p:nvSpPr>
+          <p:cNvPr id="15" name="Shape 13"/>
+          <p:cNvSpPr/>
+          <p:nvPr/>
+        </p:nvSpPr>
+        <p:spPr>
+          <a:xfrm>
+            <a:off x="1650838" y="1614262"/>
+            <a:ext cx="115873" cy="115873"/>
+          </a:xfrm>
+          <a:prstGeom prst="ellipse">
+            <a:avLst/>
+          </a:prstGeom>
+          <a:solidFill>
+            <a:srgbClr val="E9EBDF"/>
+          </a:solidFill>
+          <a:ln/>
+        </p:spPr>
+      </p:sp>
+      <p:sp>
+        <p:nvSpPr>
+          <p:cNvPr id="16" name="Shape 14"/>
+          <p:cNvSpPr/>
+          <p:nvPr/>
+        </p:nvSpPr>
+        <p:spPr>
+          <a:xfrm>
+            <a:off x="1475110" y="1438534"/>
+            <a:ext cx="85588" cy="85588"/>
+          </a:xfrm>
+          <a:prstGeom prst="ellipse">
+            <a:avLst/>
+          </a:prstGeom>
+          <a:solidFill>
+            <a:srgbClr val="E9EBDF"/>
+          </a:solidFill>
+          <a:ln/>
+        </p:spPr>
+      </p:sp>
+      <p:sp>
+        <p:nvSpPr>
+          <p:cNvPr id="17" name="Text 15"/>
           <p:cNvSpPr/>
           <p:nvPr/>
         </p:nvSpPr>
@@ -2271,7 +2565,7 @@
       </p:sp>
       <p:sp>
         <p:nvSpPr>
-          <p:cNvPr id="4" name="Text 2"/>
+          <p:cNvPr id="18" name="Text 16"/>
           <p:cNvSpPr/>
           <p:nvPr/>
         </p:nvSpPr>
@@ -2310,7 +2604,7 @@
       </p:sp>
       <p:sp>
         <p:nvSpPr>
-          <p:cNvPr id="5" name="Shape 3"/>
+          <p:cNvPr id="19" name="Shape 17"/>
           <p:cNvSpPr/>
           <p:nvPr/>
         </p:nvSpPr>
@@ -2330,7 +2624,7 @@
       </p:sp>
       <p:sp>
         <p:nvSpPr>
-          <p:cNvPr id="6" name="Text 4"/>
+          <p:cNvPr id="20" name="Text 18"/>
           <p:cNvSpPr/>
           <p:nvPr/>
         </p:nvSpPr>
@@ -2372,7 +2666,7 @@
       </p:sp>
       <p:sp>
         <p:nvSpPr>
-          <p:cNvPr id="7" name="Text 5"/>
+          <p:cNvPr id="21" name="Text 19"/>
           <p:cNvSpPr/>
           <p:nvPr/>
         </p:nvSpPr>
@@ -6126,7 +6420,301 @@
       </p:sp>
       <p:sp>
         <p:nvSpPr>
-          <p:cNvPr id="3" name="Text 1"/>
+          <p:cNvPr id="3" name="Shape 1"/>
+          <p:cNvSpPr/>
+          <p:nvPr/>
+        </p:nvSpPr>
+        <p:spPr>
+          <a:xfrm>
+            <a:off x="1247973" y="1481328"/>
+            <a:ext cx="539862" cy="0"/>
+          </a:xfrm>
+          <a:prstGeom prst="line">
+            <a:avLst/>
+          </a:prstGeom>
+          <a:noFill/>
+          <a:ln w="27651">
+            <a:solidFill>
+              <a:srgbClr val="E9EBDF"/>
+            </a:solidFill>
+            <a:prstDash val="solid"/>
+          </a:ln>
+        </p:spPr>
+      </p:sp>
+      <p:sp>
+        <p:nvSpPr>
+          <p:cNvPr id="4" name="Shape 2"/>
+          <p:cNvSpPr/>
+          <p:nvPr/>
+        </p:nvSpPr>
+        <p:spPr>
+          <a:xfrm>
+            <a:off x="1517904" y="1211397"/>
+            <a:ext cx="0" cy="539862"/>
+          </a:xfrm>
+          <a:prstGeom prst="line">
+            <a:avLst/>
+          </a:prstGeom>
+          <a:noFill/>
+          <a:ln w="27651">
+            <a:solidFill>
+              <a:srgbClr val="E9EBDF"/>
+            </a:solidFill>
+            <a:prstDash val="solid"/>
+          </a:ln>
+        </p:spPr>
+      </p:sp>
+      <p:sp>
+        <p:nvSpPr>
+          <p:cNvPr id="5" name="Shape 3"/>
+          <p:cNvSpPr/>
+          <p:nvPr/>
+        </p:nvSpPr>
+        <p:spPr>
+          <a:xfrm>
+            <a:off x="1327036" y="1290460"/>
+            <a:ext cx="381736" cy="381736"/>
+          </a:xfrm>
+          <a:prstGeom prst="line">
+            <a:avLst/>
+          </a:prstGeom>
+          <a:noFill/>
+          <a:ln w="27651">
+            <a:solidFill>
+              <a:srgbClr val="E9EBDF"/>
+            </a:solidFill>
+            <a:prstDash val="solid"/>
+          </a:ln>
+        </p:spPr>
+      </p:sp>
+      <p:sp>
+        <p:nvSpPr>
+          <p:cNvPr id="6" name="Shape 4"/>
+          <p:cNvSpPr/>
+          <p:nvPr/>
+        </p:nvSpPr>
+        <p:spPr>
+          <a:xfrm flipV="1">
+            <a:off x="1327036" y="1290460"/>
+            <a:ext cx="381736" cy="381736"/>
+          </a:xfrm>
+          <a:prstGeom prst="line">
+            <a:avLst/>
+          </a:prstGeom>
+          <a:noFill/>
+          <a:ln w="27651">
+            <a:solidFill>
+              <a:srgbClr val="E9EBDF"/>
+            </a:solidFill>
+            <a:prstDash val="solid"/>
+          </a:ln>
+        </p:spPr>
+      </p:sp>
+      <p:sp>
+        <p:nvSpPr>
+          <p:cNvPr id="7" name="Shape 5"/>
+          <p:cNvSpPr/>
+          <p:nvPr/>
+        </p:nvSpPr>
+        <p:spPr>
+          <a:xfrm>
+            <a:off x="1350020" y="1313444"/>
+            <a:ext cx="335768" cy="335768"/>
+          </a:xfrm>
+          <a:prstGeom prst="ellipse">
+            <a:avLst/>
+          </a:prstGeom>
+          <a:ln w="27651">
+            <a:solidFill>
+              <a:srgbClr val="E9EBDF"/>
+            </a:solidFill>
+            <a:prstDash val="solid"/>
+          </a:ln>
+        </p:spPr>
+      </p:sp>
+      <p:sp>
+        <p:nvSpPr>
+          <p:cNvPr id="8" name="Shape 6"/>
+          <p:cNvSpPr/>
+          <p:nvPr/>
+        </p:nvSpPr>
+        <p:spPr>
+          <a:xfrm>
+            <a:off x="1729898" y="1423392"/>
+            <a:ext cx="115873" cy="115873"/>
+          </a:xfrm>
+          <a:prstGeom prst="ellipse">
+            <a:avLst/>
+          </a:prstGeom>
+          <a:solidFill>
+            <a:srgbClr val="E9EBDF"/>
+          </a:solidFill>
+          <a:ln/>
+        </p:spPr>
+      </p:sp>
+      <p:sp>
+        <p:nvSpPr>
+          <p:cNvPr id="9" name="Shape 7"/>
+          <p:cNvSpPr/>
+          <p:nvPr/>
+        </p:nvSpPr>
+        <p:spPr>
+          <a:xfrm>
+            <a:off x="1650838" y="1232522"/>
+            <a:ext cx="115873" cy="115873"/>
+          </a:xfrm>
+          <a:prstGeom prst="ellipse">
+            <a:avLst/>
+          </a:prstGeom>
+          <a:solidFill>
+            <a:srgbClr val="E9EBDF"/>
+          </a:solidFill>
+          <a:ln/>
+        </p:spPr>
+      </p:sp>
+      <p:sp>
+        <p:nvSpPr>
+          <p:cNvPr id="10" name="Shape 8"/>
+          <p:cNvSpPr/>
+          <p:nvPr/>
+        </p:nvSpPr>
+        <p:spPr>
+          <a:xfrm>
+            <a:off x="1459968" y="1153461"/>
+            <a:ext cx="115873" cy="115873"/>
+          </a:xfrm>
+          <a:prstGeom prst="ellipse">
+            <a:avLst/>
+          </a:prstGeom>
+          <a:solidFill>
+            <a:srgbClr val="E9EBDF"/>
+          </a:solidFill>
+          <a:ln/>
+        </p:spPr>
+      </p:sp>
+      <p:sp>
+        <p:nvSpPr>
+          <p:cNvPr id="11" name="Shape 9"/>
+          <p:cNvSpPr/>
+          <p:nvPr/>
+        </p:nvSpPr>
+        <p:spPr>
+          <a:xfrm>
+            <a:off x="1269098" y="1232522"/>
+            <a:ext cx="115873" cy="115873"/>
+          </a:xfrm>
+          <a:prstGeom prst="ellipse">
+            <a:avLst/>
+          </a:prstGeom>
+          <a:solidFill>
+            <a:srgbClr val="E9EBDF"/>
+          </a:solidFill>
+          <a:ln/>
+        </p:spPr>
+      </p:sp>
+      <p:sp>
+        <p:nvSpPr>
+          <p:cNvPr id="12" name="Shape 10"/>
+          <p:cNvSpPr/>
+          <p:nvPr/>
+        </p:nvSpPr>
+        <p:spPr>
+          <a:xfrm>
+            <a:off x="1190037" y="1423392"/>
+            <a:ext cx="115873" cy="115873"/>
+          </a:xfrm>
+          <a:prstGeom prst="ellipse">
+            <a:avLst/>
+          </a:prstGeom>
+          <a:solidFill>
+            <a:srgbClr val="E9EBDF"/>
+          </a:solidFill>
+          <a:ln/>
+        </p:spPr>
+      </p:sp>
+      <p:sp>
+        <p:nvSpPr>
+          <p:cNvPr id="13" name="Shape 11"/>
+          <p:cNvSpPr/>
+          <p:nvPr/>
+        </p:nvSpPr>
+        <p:spPr>
+          <a:xfrm>
+            <a:off x="1269098" y="1614262"/>
+            <a:ext cx="115873" cy="115873"/>
+          </a:xfrm>
+          <a:prstGeom prst="ellipse">
+            <a:avLst/>
+          </a:prstGeom>
+          <a:solidFill>
+            <a:srgbClr val="E9EBDF"/>
+          </a:solidFill>
+          <a:ln/>
+        </p:spPr>
+      </p:sp>
+      <p:sp>
+        <p:nvSpPr>
+          <p:cNvPr id="14" name="Shape 12"/>
+          <p:cNvSpPr/>
+          <p:nvPr/>
+        </p:nvSpPr>
+        <p:spPr>
+          <a:xfrm>
+            <a:off x="1459968" y="1693322"/>
+            <a:ext cx="115873" cy="115873"/>
+          </a:xfrm>
+          <a:prstGeom prst="ellipse">
+            <a:avLst/>
+          </a:prstGeom>
+          <a:solidFill>
+            <a:srgbClr val="E9EBDF"/>
+          </a:solidFill>
+          <a:ln/>
+        </p:spPr>
+      </p:sp>
+      <p:sp>
+        <p:nvSpPr>
+          <p:cNvPr id="15" name="Shape 13"/>
+          <p:cNvSpPr/>
+          <p:nvPr/>
+        </p:nvSpPr>
+        <p:spPr>
+          <a:xfrm>
+            <a:off x="1650838" y="1614262"/>
+            <a:ext cx="115873" cy="115873"/>
+          </a:xfrm>
+          <a:prstGeom prst="ellipse">
+            <a:avLst/>
+          </a:prstGeom>
+          <a:solidFill>
+            <a:srgbClr val="E9EBDF"/>
+          </a:solidFill>
+          <a:ln/>
+        </p:spPr>
+      </p:sp>
+      <p:sp>
+        <p:nvSpPr>
+          <p:cNvPr id="16" name="Shape 14"/>
+          <p:cNvSpPr/>
+          <p:nvPr/>
+        </p:nvSpPr>
+        <p:spPr>
+          <a:xfrm>
+            <a:off x="1475110" y="1438534"/>
+            <a:ext cx="85588" cy="85588"/>
+          </a:xfrm>
+          <a:prstGeom prst="ellipse">
+            <a:avLst/>
+          </a:prstGeom>
+          <a:solidFill>
+            <a:srgbClr val="E9EBDF"/>
+          </a:solidFill>
+          <a:ln/>
+        </p:spPr>
+      </p:sp>
+      <p:sp>
+        <p:nvSpPr>
+          <p:cNvPr id="17" name="Text 15"/>
           <p:cNvSpPr/>
           <p:nvPr/>
         </p:nvSpPr>
@@ -6165,7 +6753,7 @@
       </p:sp>
       <p:sp>
         <p:nvSpPr>
-          <p:cNvPr id="4" name="Text 2"/>
+          <p:cNvPr id="18" name="Text 16"/>
           <p:cNvSpPr/>
           <p:nvPr/>
         </p:nvSpPr>
@@ -6204,7 +6792,7 @@
       </p:sp>
       <p:sp>
         <p:nvSpPr>
-          <p:cNvPr id="5" name="Shape 3"/>
+          <p:cNvPr id="19" name="Shape 17"/>
           <p:cNvSpPr/>
           <p:nvPr/>
         </p:nvSpPr>
@@ -6224,7 +6812,7 @@
       </p:sp>
       <p:sp>
         <p:nvSpPr>
-          <p:cNvPr id="6" name="Text 4"/>
+          <p:cNvPr id="20" name="Text 18"/>
           <p:cNvSpPr/>
           <p:nvPr/>
         </p:nvSpPr>
@@ -6266,7 +6854,7 @@
       </p:sp>
       <p:sp>
         <p:nvSpPr>
-          <p:cNvPr id="7" name="Text 5"/>
+          <p:cNvPr id="21" name="Text 19"/>
           <p:cNvSpPr/>
           <p:nvPr/>
         </p:nvSpPr>

</xml_diff>